<commit_message>
main components of dispersion ready.
</commit_message>
<xml_diff>
--- a/Data/analysis/04_dispersion/GN_Fe800meV_en_cuts_[110].pptx
+++ b/Data/analysis/04_dispersion/GN_Fe800meV_en_cuts_[110].pptx
@@ -270,7 +270,7 @@
           <a:p>
             <a:fld id="{D03C9A7F-A4D0-47D6-B3FA-3E3F62E0CCCD}" type="datetimeFigureOut">
               <a:rPr lang="en-GB" smtClean="0"/>
-              <a:t>24/03/2026</a:t>
+              <a:t>31/03/2026</a:t>
             </a:fld>
             <a:endParaRPr lang="en-GB"/>
           </a:p>
@@ -470,7 +470,7 @@
           <a:p>
             <a:fld id="{D03C9A7F-A4D0-47D6-B3FA-3E3F62E0CCCD}" type="datetimeFigureOut">
               <a:rPr lang="en-GB" smtClean="0"/>
-              <a:t>24/03/2026</a:t>
+              <a:t>31/03/2026</a:t>
             </a:fld>
             <a:endParaRPr lang="en-GB"/>
           </a:p>
@@ -680,7 +680,7 @@
           <a:p>
             <a:fld id="{D03C9A7F-A4D0-47D6-B3FA-3E3F62E0CCCD}" type="datetimeFigureOut">
               <a:rPr lang="en-GB" smtClean="0"/>
-              <a:t>24/03/2026</a:t>
+              <a:t>31/03/2026</a:t>
             </a:fld>
             <a:endParaRPr lang="en-GB"/>
           </a:p>
@@ -880,7 +880,7 @@
           <a:p>
             <a:fld id="{D03C9A7F-A4D0-47D6-B3FA-3E3F62E0CCCD}" type="datetimeFigureOut">
               <a:rPr lang="en-GB" smtClean="0"/>
-              <a:t>24/03/2026</a:t>
+              <a:t>31/03/2026</a:t>
             </a:fld>
             <a:endParaRPr lang="en-GB"/>
           </a:p>
@@ -1156,7 +1156,7 @@
           <a:p>
             <a:fld id="{D03C9A7F-A4D0-47D6-B3FA-3E3F62E0CCCD}" type="datetimeFigureOut">
               <a:rPr lang="en-GB" smtClean="0"/>
-              <a:t>24/03/2026</a:t>
+              <a:t>31/03/2026</a:t>
             </a:fld>
             <a:endParaRPr lang="en-GB"/>
           </a:p>
@@ -1424,7 +1424,7 @@
           <a:p>
             <a:fld id="{D03C9A7F-A4D0-47D6-B3FA-3E3F62E0CCCD}" type="datetimeFigureOut">
               <a:rPr lang="en-GB" smtClean="0"/>
-              <a:t>24/03/2026</a:t>
+              <a:t>31/03/2026</a:t>
             </a:fld>
             <a:endParaRPr lang="en-GB"/>
           </a:p>
@@ -1839,7 +1839,7 @@
           <a:p>
             <a:fld id="{D03C9A7F-A4D0-47D6-B3FA-3E3F62E0CCCD}" type="datetimeFigureOut">
               <a:rPr lang="en-GB" smtClean="0"/>
-              <a:t>24/03/2026</a:t>
+              <a:t>31/03/2026</a:t>
             </a:fld>
             <a:endParaRPr lang="en-GB"/>
           </a:p>
@@ -1981,7 +1981,7 @@
           <a:p>
             <a:fld id="{D03C9A7F-A4D0-47D6-B3FA-3E3F62E0CCCD}" type="datetimeFigureOut">
               <a:rPr lang="en-GB" smtClean="0"/>
-              <a:t>24/03/2026</a:t>
+              <a:t>31/03/2026</a:t>
             </a:fld>
             <a:endParaRPr lang="en-GB"/>
           </a:p>
@@ -2094,7 +2094,7 @@
           <a:p>
             <a:fld id="{D03C9A7F-A4D0-47D6-B3FA-3E3F62E0CCCD}" type="datetimeFigureOut">
               <a:rPr lang="en-GB" smtClean="0"/>
-              <a:t>24/03/2026</a:t>
+              <a:t>31/03/2026</a:t>
             </a:fld>
             <a:endParaRPr lang="en-GB"/>
           </a:p>
@@ -2407,7 +2407,7 @@
           <a:p>
             <a:fld id="{D03C9A7F-A4D0-47D6-B3FA-3E3F62E0CCCD}" type="datetimeFigureOut">
               <a:rPr lang="en-GB" smtClean="0"/>
-              <a:t>24/03/2026</a:t>
+              <a:t>31/03/2026</a:t>
             </a:fld>
             <a:endParaRPr lang="en-GB"/>
           </a:p>
@@ -2696,7 +2696,7 @@
           <a:p>
             <a:fld id="{D03C9A7F-A4D0-47D6-B3FA-3E3F62E0CCCD}" type="datetimeFigureOut">
               <a:rPr lang="en-GB" smtClean="0"/>
-              <a:t>24/03/2026</a:t>
+              <a:t>31/03/2026</a:t>
             </a:fld>
             <a:endParaRPr lang="en-GB"/>
           </a:p>
@@ -2939,7 +2939,7 @@
           <a:p>
             <a:fld id="{D03C9A7F-A4D0-47D6-B3FA-3E3F62E0CCCD}" type="datetimeFigureOut">
               <a:rPr lang="en-GB" smtClean="0"/>
-              <a:t>24/03/2026</a:t>
+              <a:t>31/03/2026</a:t>
             </a:fld>
             <a:endParaRPr lang="en-GB"/>
           </a:p>
@@ -4822,12 +4822,227 @@
           </a:prstGeom>
         </p:spPr>
       </p:pic>
-      <p:sp>
-        <p:nvSpPr>
-          <p:cNvPr id="8" name="Rectangle 7">
-            <a:extLst>
-              <a:ext uri="{FF2B5EF4-FFF2-40B4-BE49-F238E27FC236}">
-                <a16:creationId xmlns:a16="http://schemas.microsoft.com/office/drawing/2014/main" id="{158850F3-C851-AC0A-5630-958B0264F946}"/>
+      <p:grpSp>
+        <p:nvGrpSpPr>
+          <p:cNvPr id="7" name="Group 6">
+            <a:extLst>
+              <a:ext uri="{FF2B5EF4-FFF2-40B4-BE49-F238E27FC236}">
+                <a16:creationId xmlns:a16="http://schemas.microsoft.com/office/drawing/2014/main" id="{9C40F9F3-6CE9-DDB4-71CF-F95E09222C04}"/>
+              </a:ext>
+            </a:extLst>
+          </p:cNvPr>
+          <p:cNvGrpSpPr/>
+          <p:nvPr/>
+        </p:nvGrpSpPr>
+        <p:grpSpPr>
+          <a:xfrm>
+            <a:off x="2125731" y="1909000"/>
+            <a:ext cx="343183" cy="667857"/>
+            <a:chOff x="2125731" y="1909000"/>
+            <a:chExt cx="343183" cy="667857"/>
+          </a:xfrm>
+        </p:grpSpPr>
+        <p:sp>
+          <p:nvSpPr>
+            <p:cNvPr id="8" name="Rectangle 7">
+              <a:extLst>
+                <a:ext uri="{FF2B5EF4-FFF2-40B4-BE49-F238E27FC236}">
+                  <a16:creationId xmlns:a16="http://schemas.microsoft.com/office/drawing/2014/main" id="{158850F3-C851-AC0A-5630-958B0264F946}"/>
+                </a:ext>
+              </a:extLst>
+            </p:cNvPr>
+            <p:cNvSpPr/>
+            <p:nvPr/>
+          </p:nvSpPr>
+          <p:spPr>
+            <a:xfrm rot="2840540">
+              <a:off x="1975219" y="2059512"/>
+              <a:ext cx="357802" cy="56777"/>
+            </a:xfrm>
+            <a:prstGeom prst="rect">
+              <a:avLst/>
+            </a:prstGeom>
+            <a:noFill/>
+            <a:ln>
+              <a:solidFill>
+                <a:srgbClr val="FF0000"/>
+              </a:solidFill>
+            </a:ln>
+          </p:spPr>
+          <p:style>
+            <a:lnRef idx="2">
+              <a:schemeClr val="accent1">
+                <a:shade val="15000"/>
+              </a:schemeClr>
+            </a:lnRef>
+            <a:fillRef idx="1">
+              <a:schemeClr val="accent1"/>
+            </a:fillRef>
+            <a:effectRef idx="0">
+              <a:schemeClr val="accent1"/>
+            </a:effectRef>
+            <a:fontRef idx="minor">
+              <a:schemeClr val="lt1"/>
+            </a:fontRef>
+          </p:style>
+          <p:txBody>
+            <a:bodyPr rtlCol="0" anchor="ctr"/>
+            <a:lstStyle/>
+            <a:p>
+              <a:pPr algn="ctr"/>
+              <a:endParaRPr lang="en-GB"/>
+            </a:p>
+          </p:txBody>
+        </p:sp>
+        <p:sp>
+          <p:nvSpPr>
+            <p:cNvPr id="2" name="Rectangle 1">
+              <a:extLst>
+                <a:ext uri="{FF2B5EF4-FFF2-40B4-BE49-F238E27FC236}">
+                  <a16:creationId xmlns:a16="http://schemas.microsoft.com/office/drawing/2014/main" id="{7B80769F-C788-DA78-D98E-07EA2F46AC1A}"/>
+                </a:ext>
+              </a:extLst>
+            </p:cNvPr>
+            <p:cNvSpPr/>
+            <p:nvPr/>
+          </p:nvSpPr>
+          <p:spPr>
+            <a:xfrm rot="2840540">
+              <a:off x="2261625" y="2369567"/>
+              <a:ext cx="357802" cy="56777"/>
+            </a:xfrm>
+            <a:prstGeom prst="rect">
+              <a:avLst/>
+            </a:prstGeom>
+            <a:noFill/>
+            <a:ln>
+              <a:solidFill>
+                <a:srgbClr val="FF0000"/>
+              </a:solidFill>
+            </a:ln>
+          </p:spPr>
+          <p:style>
+            <a:lnRef idx="2">
+              <a:schemeClr val="accent1">
+                <a:shade val="15000"/>
+              </a:schemeClr>
+            </a:lnRef>
+            <a:fillRef idx="1">
+              <a:schemeClr val="accent1"/>
+            </a:fillRef>
+            <a:effectRef idx="0">
+              <a:schemeClr val="accent1"/>
+            </a:effectRef>
+            <a:fontRef idx="minor">
+              <a:schemeClr val="lt1"/>
+            </a:fontRef>
+          </p:style>
+          <p:txBody>
+            <a:bodyPr rtlCol="0" anchor="ctr"/>
+            <a:lstStyle/>
+            <a:p>
+              <a:pPr algn="ctr"/>
+              <a:endParaRPr lang="en-GB"/>
+            </a:p>
+          </p:txBody>
+        </p:sp>
+      </p:grpSp>
+      <p:pic>
+        <p:nvPicPr>
+          <p:cNvPr id="4" name="Picture 3">
+            <a:extLst>
+              <a:ext uri="{FF2B5EF4-FFF2-40B4-BE49-F238E27FC236}">
+                <a16:creationId xmlns:a16="http://schemas.microsoft.com/office/drawing/2014/main" id="{A84334FA-6C20-3A47-681D-418D7873D822}"/>
+              </a:ext>
+            </a:extLst>
+          </p:cNvPr>
+          <p:cNvPicPr>
+            <a:picLocks noChangeAspect="1"/>
+          </p:cNvPicPr>
+          <p:nvPr/>
+        </p:nvPicPr>
+        <p:blipFill>
+          <a:blip r:embed="rId3"/>
+          <a:stretch>
+            <a:fillRect/>
+          </a:stretch>
+        </p:blipFill>
+        <p:spPr>
+          <a:xfrm>
+            <a:off x="7102699" y="121544"/>
+            <a:ext cx="3830392" cy="2872794"/>
+          </a:xfrm>
+          <a:prstGeom prst="rect">
+            <a:avLst/>
+          </a:prstGeom>
+        </p:spPr>
+      </p:pic>
+      <p:pic>
+        <p:nvPicPr>
+          <p:cNvPr id="9" name="Picture 8">
+            <a:extLst>
+              <a:ext uri="{FF2B5EF4-FFF2-40B4-BE49-F238E27FC236}">
+                <a16:creationId xmlns:a16="http://schemas.microsoft.com/office/drawing/2014/main" id="{437DCF0A-DFC2-499C-9F15-B57E57986A2A}"/>
+              </a:ext>
+            </a:extLst>
+          </p:cNvPr>
+          <p:cNvPicPr>
+            <a:picLocks noChangeAspect="1"/>
+          </p:cNvPicPr>
+          <p:nvPr/>
+        </p:nvPicPr>
+        <p:blipFill>
+          <a:blip r:embed="rId4"/>
+          <a:stretch>
+            <a:fillRect/>
+          </a:stretch>
+        </p:blipFill>
+        <p:spPr>
+          <a:xfrm>
+            <a:off x="245697" y="3574109"/>
+            <a:ext cx="3924836" cy="2943627"/>
+          </a:xfrm>
+          <a:prstGeom prst="rect">
+            <a:avLst/>
+          </a:prstGeom>
+        </p:spPr>
+      </p:pic>
+      <p:pic>
+        <p:nvPicPr>
+          <p:cNvPr id="12" name="Picture 11">
+            <a:extLst>
+              <a:ext uri="{FF2B5EF4-FFF2-40B4-BE49-F238E27FC236}">
+                <a16:creationId xmlns:a16="http://schemas.microsoft.com/office/drawing/2014/main" id="{9C3F7245-123B-F993-D32B-EB0AC044B01A}"/>
+              </a:ext>
+            </a:extLst>
+          </p:cNvPr>
+          <p:cNvPicPr>
+            <a:picLocks noChangeAspect="1"/>
+          </p:cNvPicPr>
+          <p:nvPr/>
+        </p:nvPicPr>
+        <p:blipFill>
+          <a:blip r:embed="rId5"/>
+          <a:stretch>
+            <a:fillRect/>
+          </a:stretch>
+        </p:blipFill>
+        <p:spPr>
+          <a:xfrm>
+            <a:off x="4054697" y="3644942"/>
+            <a:ext cx="3735947" cy="2801960"/>
+          </a:xfrm>
+          <a:prstGeom prst="rect">
+            <a:avLst/>
+          </a:prstGeom>
+        </p:spPr>
+      </p:pic>
+      <p:sp>
+        <p:nvSpPr>
+          <p:cNvPr id="14" name="Rectangle 13">
+            <a:extLst>
+              <a:ext uri="{FF2B5EF4-FFF2-40B4-BE49-F238E27FC236}">
+                <a16:creationId xmlns:a16="http://schemas.microsoft.com/office/drawing/2014/main" id="{0AAAEBF8-4C8F-B461-D65E-672CBD56091C}"/>
               </a:ext>
             </a:extLst>
           </p:cNvPr>
@@ -4835,9 +5050,9 @@
           <p:nvPr/>
         </p:nvSpPr>
         <p:spPr>
-          <a:xfrm rot="2840540">
-            <a:off x="1975219" y="2059512"/>
-            <a:ext cx="357802" cy="56777"/>
+          <a:xfrm rot="5400000">
+            <a:off x="917909" y="4753792"/>
+            <a:ext cx="1575634" cy="52958"/>
           </a:xfrm>
           <a:prstGeom prst="rect">
             <a:avLst/>
@@ -4874,12 +5089,400 @@
           </a:p>
         </p:txBody>
       </p:sp>
-      <p:sp>
-        <p:nvSpPr>
-          <p:cNvPr id="2" name="Rectangle 1">
-            <a:extLst>
-              <a:ext uri="{FF2B5EF4-FFF2-40B4-BE49-F238E27FC236}">
-                <a16:creationId xmlns:a16="http://schemas.microsoft.com/office/drawing/2014/main" id="{7B80769F-C788-DA78-D98E-07EA2F46AC1A}"/>
+      <p:pic>
+        <p:nvPicPr>
+          <p:cNvPr id="16" name="Picture 15">
+            <a:extLst>
+              <a:ext uri="{FF2B5EF4-FFF2-40B4-BE49-F238E27FC236}">
+                <a16:creationId xmlns:a16="http://schemas.microsoft.com/office/drawing/2014/main" id="{B8E225F7-B916-B9DA-3257-DAB443F1E45C}"/>
+              </a:ext>
+            </a:extLst>
+          </p:cNvPr>
+          <p:cNvPicPr>
+            <a:picLocks noChangeAspect="1"/>
+          </p:cNvPicPr>
+          <p:nvPr/>
+        </p:nvPicPr>
+        <p:blipFill>
+          <a:blip r:embed="rId6"/>
+          <a:stretch>
+            <a:fillRect/>
+          </a:stretch>
+        </p:blipFill>
+        <p:spPr>
+          <a:xfrm>
+            <a:off x="7790644" y="3725840"/>
+            <a:ext cx="4170124" cy="2640163"/>
+          </a:xfrm>
+          <a:prstGeom prst="rect">
+            <a:avLst/>
+          </a:prstGeom>
+        </p:spPr>
+      </p:pic>
+      <p:sp>
+        <p:nvSpPr>
+          <p:cNvPr id="17" name="TextBox 16">
+            <a:extLst>
+              <a:ext uri="{FF2B5EF4-FFF2-40B4-BE49-F238E27FC236}">
+                <a16:creationId xmlns:a16="http://schemas.microsoft.com/office/drawing/2014/main" id="{04A20AFE-2913-762E-7F9E-0A5E718584D3}"/>
+              </a:ext>
+            </a:extLst>
+          </p:cNvPr>
+          <p:cNvSpPr txBox="1"/>
+          <p:nvPr/>
+        </p:nvSpPr>
+        <p:spPr>
+          <a:xfrm>
+            <a:off x="4705225" y="57311"/>
+            <a:ext cx="511679" cy="369332"/>
+          </a:xfrm>
+          <a:prstGeom prst="rect">
+            <a:avLst/>
+          </a:prstGeom>
+          <a:noFill/>
+        </p:spPr>
+        <p:txBody>
+          <a:bodyPr wrap="none" rtlCol="0">
+            <a:spAutoFit/>
+          </a:bodyPr>
+          <a:lstStyle/>
+          <a:p>
+            <a:r>
+              <a:rPr lang="en-GB" dirty="0"/>
+              <a:t>GN</a:t>
+            </a:r>
+          </a:p>
+        </p:txBody>
+      </p:sp>
+      <p:sp>
+        <p:nvSpPr>
+          <p:cNvPr id="18" name="TextBox 17">
+            <a:extLst>
+              <a:ext uri="{FF2B5EF4-FFF2-40B4-BE49-F238E27FC236}">
+                <a16:creationId xmlns:a16="http://schemas.microsoft.com/office/drawing/2014/main" id="{D209496E-C7B9-EB14-3946-1F7F95381ED4}"/>
+              </a:ext>
+            </a:extLst>
+          </p:cNvPr>
+          <p:cNvSpPr txBox="1"/>
+          <p:nvPr/>
+        </p:nvSpPr>
+        <p:spPr>
+          <a:xfrm>
+            <a:off x="9092485" y="595764"/>
+            <a:ext cx="1376018" cy="369332"/>
+          </a:xfrm>
+          <a:prstGeom prst="rect">
+            <a:avLst/>
+          </a:prstGeom>
+          <a:noFill/>
+        </p:spPr>
+        <p:txBody>
+          <a:bodyPr wrap="none" rtlCol="0">
+            <a:spAutoFit/>
+          </a:bodyPr>
+          <a:lstStyle/>
+          <a:p>
+            <a:r>
+              <a:rPr lang="en-GB" dirty="0"/>
+              <a:t>Background</a:t>
+            </a:r>
+          </a:p>
+        </p:txBody>
+      </p:sp>
+      <p:pic>
+        <p:nvPicPr>
+          <p:cNvPr id="6" name="Picture 5">
+            <a:extLst>
+              <a:ext uri="{FF2B5EF4-FFF2-40B4-BE49-F238E27FC236}">
+                <a16:creationId xmlns:a16="http://schemas.microsoft.com/office/drawing/2014/main" id="{1C9DE91B-4924-D150-33D1-3EF3FFEDA30F}"/>
+              </a:ext>
+            </a:extLst>
+          </p:cNvPr>
+          <p:cNvPicPr>
+            <a:picLocks noChangeAspect="1"/>
+          </p:cNvPicPr>
+          <p:nvPr/>
+        </p:nvPicPr>
+        <p:blipFill>
+          <a:blip r:embed="rId7"/>
+          <a:stretch>
+            <a:fillRect/>
+          </a:stretch>
+        </p:blipFill>
+        <p:spPr>
+          <a:xfrm>
+            <a:off x="3922449" y="513022"/>
+            <a:ext cx="3128075" cy="2346056"/>
+          </a:xfrm>
+          <a:prstGeom prst="rect">
+            <a:avLst/>
+          </a:prstGeom>
+        </p:spPr>
+      </p:pic>
+      <p:grpSp>
+        <p:nvGrpSpPr>
+          <p:cNvPr id="10" name="Group 9">
+            <a:extLst>
+              <a:ext uri="{FF2B5EF4-FFF2-40B4-BE49-F238E27FC236}">
+                <a16:creationId xmlns:a16="http://schemas.microsoft.com/office/drawing/2014/main" id="{CF976F3A-AE38-EE63-17A1-1C9FE56E755B}"/>
+              </a:ext>
+            </a:extLst>
+          </p:cNvPr>
+          <p:cNvGrpSpPr/>
+          <p:nvPr/>
+        </p:nvGrpSpPr>
+        <p:grpSpPr>
+          <a:xfrm rot="16200000">
+            <a:off x="1904647" y="1803823"/>
+            <a:ext cx="343183" cy="667857"/>
+            <a:chOff x="2125731" y="1909000"/>
+            <a:chExt cx="343183" cy="667857"/>
+          </a:xfrm>
+        </p:grpSpPr>
+        <p:sp>
+          <p:nvSpPr>
+            <p:cNvPr id="11" name="Rectangle 10">
+              <a:extLst>
+                <a:ext uri="{FF2B5EF4-FFF2-40B4-BE49-F238E27FC236}">
+                  <a16:creationId xmlns:a16="http://schemas.microsoft.com/office/drawing/2014/main" id="{D950C7DD-550E-9D03-BA1E-1F8B08B42836}"/>
+                </a:ext>
+              </a:extLst>
+            </p:cNvPr>
+            <p:cNvSpPr/>
+            <p:nvPr/>
+          </p:nvSpPr>
+          <p:spPr>
+            <a:xfrm rot="2840540">
+              <a:off x="1975219" y="2059512"/>
+              <a:ext cx="357802" cy="56777"/>
+            </a:xfrm>
+            <a:prstGeom prst="rect">
+              <a:avLst/>
+            </a:prstGeom>
+            <a:noFill/>
+            <a:ln>
+              <a:solidFill>
+                <a:schemeClr val="accent2">
+                  <a:lumMod val="50000"/>
+                </a:schemeClr>
+              </a:solidFill>
+            </a:ln>
+          </p:spPr>
+          <p:style>
+            <a:lnRef idx="2">
+              <a:schemeClr val="accent1">
+                <a:shade val="15000"/>
+              </a:schemeClr>
+            </a:lnRef>
+            <a:fillRef idx="1">
+              <a:schemeClr val="accent1"/>
+            </a:fillRef>
+            <a:effectRef idx="0">
+              <a:schemeClr val="accent1"/>
+            </a:effectRef>
+            <a:fontRef idx="minor">
+              <a:schemeClr val="lt1"/>
+            </a:fontRef>
+          </p:style>
+          <p:txBody>
+            <a:bodyPr rtlCol="0" anchor="ctr"/>
+            <a:lstStyle/>
+            <a:p>
+              <a:pPr algn="ctr"/>
+              <a:endParaRPr lang="en-GB"/>
+            </a:p>
+          </p:txBody>
+        </p:sp>
+        <p:sp>
+          <p:nvSpPr>
+            <p:cNvPr id="13" name="Rectangle 12">
+              <a:extLst>
+                <a:ext uri="{FF2B5EF4-FFF2-40B4-BE49-F238E27FC236}">
+                  <a16:creationId xmlns:a16="http://schemas.microsoft.com/office/drawing/2014/main" id="{C5B0D2C5-A10A-5666-9E43-EE8751E25A1A}"/>
+                </a:ext>
+              </a:extLst>
+            </p:cNvPr>
+            <p:cNvSpPr/>
+            <p:nvPr/>
+          </p:nvSpPr>
+          <p:spPr>
+            <a:xfrm rot="2840540">
+              <a:off x="2261625" y="2369567"/>
+              <a:ext cx="357802" cy="56777"/>
+            </a:xfrm>
+            <a:prstGeom prst="rect">
+              <a:avLst/>
+            </a:prstGeom>
+            <a:noFill/>
+            <a:ln>
+              <a:solidFill>
+                <a:schemeClr val="accent2">
+                  <a:lumMod val="50000"/>
+                </a:schemeClr>
+              </a:solidFill>
+            </a:ln>
+          </p:spPr>
+          <p:style>
+            <a:lnRef idx="2">
+              <a:schemeClr val="accent1">
+                <a:shade val="15000"/>
+              </a:schemeClr>
+            </a:lnRef>
+            <a:fillRef idx="1">
+              <a:schemeClr val="accent1"/>
+            </a:fillRef>
+            <a:effectRef idx="0">
+              <a:schemeClr val="accent1"/>
+            </a:effectRef>
+            <a:fontRef idx="minor">
+              <a:schemeClr val="lt1"/>
+            </a:fontRef>
+          </p:style>
+          <p:txBody>
+            <a:bodyPr rtlCol="0" anchor="ctr"/>
+            <a:lstStyle/>
+            <a:p>
+              <a:pPr algn="ctr"/>
+              <a:endParaRPr lang="en-GB"/>
+            </a:p>
+          </p:txBody>
+        </p:sp>
+      </p:grpSp>
+      <p:grpSp>
+        <p:nvGrpSpPr>
+          <p:cNvPr id="15" name="Group 14">
+            <a:extLst>
+              <a:ext uri="{FF2B5EF4-FFF2-40B4-BE49-F238E27FC236}">
+                <a16:creationId xmlns:a16="http://schemas.microsoft.com/office/drawing/2014/main" id="{F226499D-5E67-C50A-C437-065ECD8209C0}"/>
+              </a:ext>
+            </a:extLst>
+          </p:cNvPr>
+          <p:cNvGrpSpPr/>
+          <p:nvPr/>
+        </p:nvGrpSpPr>
+        <p:grpSpPr>
+          <a:xfrm rot="16200000">
+            <a:off x="2222586" y="2208470"/>
+            <a:ext cx="343183" cy="667857"/>
+            <a:chOff x="2125731" y="1909000"/>
+            <a:chExt cx="343183" cy="667857"/>
+          </a:xfrm>
+        </p:grpSpPr>
+        <p:sp>
+          <p:nvSpPr>
+            <p:cNvPr id="19" name="Rectangle 18">
+              <a:extLst>
+                <a:ext uri="{FF2B5EF4-FFF2-40B4-BE49-F238E27FC236}">
+                  <a16:creationId xmlns:a16="http://schemas.microsoft.com/office/drawing/2014/main" id="{6553E974-0750-95ED-0AB2-62F4BEF2B3C6}"/>
+                </a:ext>
+              </a:extLst>
+            </p:cNvPr>
+            <p:cNvSpPr/>
+            <p:nvPr/>
+          </p:nvSpPr>
+          <p:spPr>
+            <a:xfrm rot="2840540">
+              <a:off x="1975219" y="2059512"/>
+              <a:ext cx="357802" cy="56777"/>
+            </a:xfrm>
+            <a:prstGeom prst="rect">
+              <a:avLst/>
+            </a:prstGeom>
+            <a:noFill/>
+            <a:ln>
+              <a:solidFill>
+                <a:schemeClr val="accent2">
+                  <a:lumMod val="50000"/>
+                </a:schemeClr>
+              </a:solidFill>
+            </a:ln>
+          </p:spPr>
+          <p:style>
+            <a:lnRef idx="2">
+              <a:schemeClr val="accent1">
+                <a:shade val="15000"/>
+              </a:schemeClr>
+            </a:lnRef>
+            <a:fillRef idx="1">
+              <a:schemeClr val="accent1"/>
+            </a:fillRef>
+            <a:effectRef idx="0">
+              <a:schemeClr val="accent1"/>
+            </a:effectRef>
+            <a:fontRef idx="minor">
+              <a:schemeClr val="lt1"/>
+            </a:fontRef>
+          </p:style>
+          <p:txBody>
+            <a:bodyPr rtlCol="0" anchor="ctr"/>
+            <a:lstStyle/>
+            <a:p>
+              <a:pPr algn="ctr"/>
+              <a:endParaRPr lang="en-GB"/>
+            </a:p>
+          </p:txBody>
+        </p:sp>
+        <p:sp>
+          <p:nvSpPr>
+            <p:cNvPr id="20" name="Rectangle 19">
+              <a:extLst>
+                <a:ext uri="{FF2B5EF4-FFF2-40B4-BE49-F238E27FC236}">
+                  <a16:creationId xmlns:a16="http://schemas.microsoft.com/office/drawing/2014/main" id="{0B9C75A2-6907-00FB-B2F1-1C453028EB0E}"/>
+                </a:ext>
+              </a:extLst>
+            </p:cNvPr>
+            <p:cNvSpPr/>
+            <p:nvPr/>
+          </p:nvSpPr>
+          <p:spPr>
+            <a:xfrm rot="2840540">
+              <a:off x="2261625" y="2369567"/>
+              <a:ext cx="357802" cy="56777"/>
+            </a:xfrm>
+            <a:prstGeom prst="rect">
+              <a:avLst/>
+            </a:prstGeom>
+            <a:noFill/>
+            <a:ln>
+              <a:solidFill>
+                <a:schemeClr val="accent2">
+                  <a:lumMod val="50000"/>
+                </a:schemeClr>
+              </a:solidFill>
+            </a:ln>
+          </p:spPr>
+          <p:style>
+            <a:lnRef idx="2">
+              <a:schemeClr val="accent1">
+                <a:shade val="15000"/>
+              </a:schemeClr>
+            </a:lnRef>
+            <a:fillRef idx="1">
+              <a:schemeClr val="accent1"/>
+            </a:fillRef>
+            <a:effectRef idx="0">
+              <a:schemeClr val="accent1"/>
+            </a:effectRef>
+            <a:fontRef idx="minor">
+              <a:schemeClr val="lt1"/>
+            </a:fontRef>
+          </p:style>
+          <p:txBody>
+            <a:bodyPr rtlCol="0" anchor="ctr"/>
+            <a:lstStyle/>
+            <a:p>
+              <a:pPr algn="ctr"/>
+              <a:endParaRPr lang="en-GB"/>
+            </a:p>
+          </p:txBody>
+        </p:sp>
+      </p:grpSp>
+      <p:sp>
+        <p:nvSpPr>
+          <p:cNvPr id="22" name="Rectangle 21">
+            <a:extLst>
+              <a:ext uri="{FF2B5EF4-FFF2-40B4-BE49-F238E27FC236}">
+                <a16:creationId xmlns:a16="http://schemas.microsoft.com/office/drawing/2014/main" id="{012D5C7D-ABEE-3A98-2BC4-80A0ECC0FEB5}"/>
               </a:ext>
             </a:extLst>
           </p:cNvPr>
@@ -4887,9 +5490,9 @@
           <p:nvPr/>
         </p:nvSpPr>
         <p:spPr>
-          <a:xfrm rot="2840540">
-            <a:off x="2261625" y="2369567"/>
-            <a:ext cx="357802" cy="56777"/>
+          <a:xfrm rot="21526896">
+            <a:off x="4609173" y="1491278"/>
+            <a:ext cx="692036" cy="115140"/>
           </a:xfrm>
           <a:prstGeom prst="rect">
             <a:avLst/>
@@ -4897,7 +5500,9 @@
           <a:noFill/>
           <a:ln>
             <a:solidFill>
-              <a:srgbClr val="FF0000"/>
+              <a:schemeClr val="accent2">
+                <a:lumMod val="50000"/>
+              </a:schemeClr>
             </a:solidFill>
           </a:ln>
         </p:spPr>
@@ -4926,102 +5531,12 @@
           </a:p>
         </p:txBody>
       </p:sp>
-      <p:pic>
-        <p:nvPicPr>
-          <p:cNvPr id="4" name="Picture 3">
-            <a:extLst>
-              <a:ext uri="{FF2B5EF4-FFF2-40B4-BE49-F238E27FC236}">
-                <a16:creationId xmlns:a16="http://schemas.microsoft.com/office/drawing/2014/main" id="{A84334FA-6C20-3A47-681D-418D7873D822}"/>
-              </a:ext>
-            </a:extLst>
-          </p:cNvPr>
-          <p:cNvPicPr>
-            <a:picLocks noChangeAspect="1"/>
-          </p:cNvPicPr>
-          <p:nvPr/>
-        </p:nvPicPr>
-        <p:blipFill>
-          <a:blip r:embed="rId3"/>
-          <a:stretch>
-            <a:fillRect/>
-          </a:stretch>
-        </p:blipFill>
-        <p:spPr>
-          <a:xfrm>
-            <a:off x="7102699" y="121544"/>
-            <a:ext cx="3830392" cy="2872794"/>
-          </a:xfrm>
-          <a:prstGeom prst="rect">
-            <a:avLst/>
-          </a:prstGeom>
-        </p:spPr>
-      </p:pic>
-      <p:pic>
-        <p:nvPicPr>
-          <p:cNvPr id="9" name="Picture 8">
-            <a:extLst>
-              <a:ext uri="{FF2B5EF4-FFF2-40B4-BE49-F238E27FC236}">
-                <a16:creationId xmlns:a16="http://schemas.microsoft.com/office/drawing/2014/main" id="{437DCF0A-DFC2-499C-9F15-B57E57986A2A}"/>
-              </a:ext>
-            </a:extLst>
-          </p:cNvPr>
-          <p:cNvPicPr>
-            <a:picLocks noChangeAspect="1"/>
-          </p:cNvPicPr>
-          <p:nvPr/>
-        </p:nvPicPr>
-        <p:blipFill>
-          <a:blip r:embed="rId4"/>
-          <a:stretch>
-            <a:fillRect/>
-          </a:stretch>
-        </p:blipFill>
-        <p:spPr>
-          <a:xfrm>
-            <a:off x="245697" y="3574109"/>
-            <a:ext cx="3924836" cy="2943627"/>
-          </a:xfrm>
-          <a:prstGeom prst="rect">
-            <a:avLst/>
-          </a:prstGeom>
-        </p:spPr>
-      </p:pic>
-      <p:pic>
-        <p:nvPicPr>
-          <p:cNvPr id="12" name="Picture 11">
-            <a:extLst>
-              <a:ext uri="{FF2B5EF4-FFF2-40B4-BE49-F238E27FC236}">
-                <a16:creationId xmlns:a16="http://schemas.microsoft.com/office/drawing/2014/main" id="{9C3F7245-123B-F993-D32B-EB0AC044B01A}"/>
-              </a:ext>
-            </a:extLst>
-          </p:cNvPr>
-          <p:cNvPicPr>
-            <a:picLocks noChangeAspect="1"/>
-          </p:cNvPicPr>
-          <p:nvPr/>
-        </p:nvPicPr>
-        <p:blipFill>
-          <a:blip r:embed="rId5"/>
-          <a:stretch>
-            <a:fillRect/>
-          </a:stretch>
-        </p:blipFill>
-        <p:spPr>
-          <a:xfrm>
-            <a:off x="4054697" y="3644942"/>
-            <a:ext cx="3735947" cy="2801960"/>
-          </a:xfrm>
-          <a:prstGeom prst="rect">
-            <a:avLst/>
-          </a:prstGeom>
-        </p:spPr>
-      </p:pic>
-      <p:sp>
-        <p:nvSpPr>
-          <p:cNvPr id="14" name="Rectangle 13">
-            <a:extLst>
-              <a:ext uri="{FF2B5EF4-FFF2-40B4-BE49-F238E27FC236}">
-                <a16:creationId xmlns:a16="http://schemas.microsoft.com/office/drawing/2014/main" id="{0AAAEBF8-4C8F-B461-D65E-672CBD56091C}"/>
+      <p:sp>
+        <p:nvSpPr>
+          <p:cNvPr id="23" name="Rectangle 22">
+            <a:extLst>
+              <a:ext uri="{FF2B5EF4-FFF2-40B4-BE49-F238E27FC236}">
+                <a16:creationId xmlns:a16="http://schemas.microsoft.com/office/drawing/2014/main" id="{28DDF8E6-ADDC-C348-01C5-20CC4A462277}"/>
               </a:ext>
             </a:extLst>
           </p:cNvPr>
@@ -5029,9 +5544,9 @@
           <p:nvPr/>
         </p:nvSpPr>
         <p:spPr>
-          <a:xfrm rot="5400000">
-            <a:off x="917909" y="4753792"/>
-            <a:ext cx="1575634" cy="52958"/>
+          <a:xfrm rot="21526896">
+            <a:off x="5443129" y="1491278"/>
+            <a:ext cx="692036" cy="115140"/>
           </a:xfrm>
           <a:prstGeom prst="rect">
             <a:avLst/>
@@ -5039,7 +5554,9 @@
           <a:noFill/>
           <a:ln>
             <a:solidFill>
-              <a:srgbClr val="FF0000"/>
+              <a:schemeClr val="accent2">
+                <a:lumMod val="50000"/>
+              </a:schemeClr>
             </a:solidFill>
           </a:ln>
         </p:spPr>
@@ -5065,106 +5582,6 @@
           <a:p>
             <a:pPr algn="ctr"/>
             <a:endParaRPr lang="en-GB"/>
-          </a:p>
-        </p:txBody>
-      </p:sp>
-      <p:pic>
-        <p:nvPicPr>
-          <p:cNvPr id="16" name="Picture 15">
-            <a:extLst>
-              <a:ext uri="{FF2B5EF4-FFF2-40B4-BE49-F238E27FC236}">
-                <a16:creationId xmlns:a16="http://schemas.microsoft.com/office/drawing/2014/main" id="{B8E225F7-B916-B9DA-3257-DAB443F1E45C}"/>
-              </a:ext>
-            </a:extLst>
-          </p:cNvPr>
-          <p:cNvPicPr>
-            <a:picLocks noChangeAspect="1"/>
-          </p:cNvPicPr>
-          <p:nvPr/>
-        </p:nvPicPr>
-        <p:blipFill>
-          <a:blip r:embed="rId6"/>
-          <a:stretch>
-            <a:fillRect/>
-          </a:stretch>
-        </p:blipFill>
-        <p:spPr>
-          <a:xfrm>
-            <a:off x="7790644" y="3725840"/>
-            <a:ext cx="4170124" cy="2640163"/>
-          </a:xfrm>
-          <a:prstGeom prst="rect">
-            <a:avLst/>
-          </a:prstGeom>
-        </p:spPr>
-      </p:pic>
-      <p:sp>
-        <p:nvSpPr>
-          <p:cNvPr id="17" name="TextBox 16">
-            <a:extLst>
-              <a:ext uri="{FF2B5EF4-FFF2-40B4-BE49-F238E27FC236}">
-                <a16:creationId xmlns:a16="http://schemas.microsoft.com/office/drawing/2014/main" id="{04A20AFE-2913-762E-7F9E-0A5E718584D3}"/>
-              </a:ext>
-            </a:extLst>
-          </p:cNvPr>
-          <p:cNvSpPr txBox="1"/>
-          <p:nvPr/>
-        </p:nvSpPr>
-        <p:spPr>
-          <a:xfrm>
-            <a:off x="4937044" y="226432"/>
-            <a:ext cx="511679" cy="369332"/>
-          </a:xfrm>
-          <a:prstGeom prst="rect">
-            <a:avLst/>
-          </a:prstGeom>
-          <a:noFill/>
-        </p:spPr>
-        <p:txBody>
-          <a:bodyPr wrap="none" rtlCol="0">
-            <a:spAutoFit/>
-          </a:bodyPr>
-          <a:lstStyle/>
-          <a:p>
-            <a:r>
-              <a:rPr lang="en-GB" dirty="0"/>
-              <a:t>GN</a:t>
-            </a:r>
-          </a:p>
-        </p:txBody>
-      </p:sp>
-      <p:sp>
-        <p:nvSpPr>
-          <p:cNvPr id="18" name="TextBox 17">
-            <a:extLst>
-              <a:ext uri="{FF2B5EF4-FFF2-40B4-BE49-F238E27FC236}">
-                <a16:creationId xmlns:a16="http://schemas.microsoft.com/office/drawing/2014/main" id="{D209496E-C7B9-EB14-3946-1F7F95381ED4}"/>
-              </a:ext>
-            </a:extLst>
-          </p:cNvPr>
-          <p:cNvSpPr txBox="1"/>
-          <p:nvPr/>
-        </p:nvSpPr>
-        <p:spPr>
-          <a:xfrm>
-            <a:off x="9092485" y="595764"/>
-            <a:ext cx="1376018" cy="369332"/>
-          </a:xfrm>
-          <a:prstGeom prst="rect">
-            <a:avLst/>
-          </a:prstGeom>
-          <a:noFill/>
-        </p:spPr>
-        <p:txBody>
-          <a:bodyPr wrap="none" rtlCol="0">
-            <a:spAutoFit/>
-          </a:bodyPr>
-          <a:lstStyle/>
-          <a:p>
-            <a:r>
-              <a:rPr lang="en-GB" dirty="0"/>
-              <a:t>Background</a:t>
-            </a:r>
           </a:p>
         </p:txBody>
       </p:sp>

</xml_diff>

<commit_message>
separated spaghetty and diagram plots. trying to fit with j0 nicely. Does not look good.
</commit_message>
<xml_diff>
--- a/Data/analysis/04_dispersion/GN_Fe800meV_en_cuts_[110].pptx
+++ b/Data/analysis/04_dispersion/GN_Fe800meV_en_cuts_[110].pptx
@@ -4,6 +4,9 @@
   <p:sldMasterIdLst>
     <p:sldMasterId id="2147483648" r:id="rId1"/>
   </p:sldMasterIdLst>
+  <p:notesMasterIdLst>
+    <p:notesMasterId r:id="rId12"/>
+  </p:notesMasterIdLst>
   <p:sldIdLst>
     <p:sldId id="256" r:id="rId2"/>
     <p:sldId id="258" r:id="rId3"/>
@@ -121,6 +124,440 @@
 </p:presentation>
 </file>
 
+<file path=ppt/notesMasters/notesMaster1.xml><?xml version="1.0" encoding="utf-8"?>
+<p:notesMaster xmlns:a="http://schemas.openxmlformats.org/drawingml/2006/main" xmlns:r="http://schemas.openxmlformats.org/officeDocument/2006/relationships" xmlns:p="http://schemas.openxmlformats.org/presentationml/2006/main">
+  <p:cSld>
+    <p:bg>
+      <p:bgRef idx="1001">
+        <a:schemeClr val="bg1"/>
+      </p:bgRef>
+    </p:bg>
+    <p:spTree>
+      <p:nvGrpSpPr>
+        <p:cNvPr id="1" name=""/>
+        <p:cNvGrpSpPr/>
+        <p:nvPr/>
+      </p:nvGrpSpPr>
+      <p:grpSpPr>
+        <a:xfrm>
+          <a:off x="0" y="0"/>
+          <a:ext cx="0" cy="0"/>
+          <a:chOff x="0" y="0"/>
+          <a:chExt cx="0" cy="0"/>
+        </a:xfrm>
+      </p:grpSpPr>
+      <p:sp>
+        <p:nvSpPr>
+          <p:cNvPr id="2" name="Header Placeholder 1"/>
+          <p:cNvSpPr>
+            <a:spLocks noGrp="1"/>
+          </p:cNvSpPr>
+          <p:nvPr>
+            <p:ph type="hdr" sz="quarter"/>
+          </p:nvPr>
+        </p:nvSpPr>
+        <p:spPr>
+          <a:xfrm>
+            <a:off x="0" y="0"/>
+            <a:ext cx="2971800" cy="458788"/>
+          </a:xfrm>
+          <a:prstGeom prst="rect">
+            <a:avLst/>
+          </a:prstGeom>
+        </p:spPr>
+        <p:txBody>
+          <a:bodyPr vert="horz" lIns="91440" tIns="45720" rIns="91440" bIns="45720" rtlCol="0"/>
+          <a:lstStyle>
+            <a:lvl1pPr algn="l">
+              <a:defRPr sz="1200"/>
+            </a:lvl1pPr>
+          </a:lstStyle>
+          <a:p>
+            <a:endParaRPr lang="en-GB"/>
+          </a:p>
+        </p:txBody>
+      </p:sp>
+      <p:sp>
+        <p:nvSpPr>
+          <p:cNvPr id="3" name="Date Placeholder 2"/>
+          <p:cNvSpPr>
+            <a:spLocks noGrp="1"/>
+          </p:cNvSpPr>
+          <p:nvPr>
+            <p:ph type="dt" idx="1"/>
+          </p:nvPr>
+        </p:nvSpPr>
+        <p:spPr>
+          <a:xfrm>
+            <a:off x="3884613" y="0"/>
+            <a:ext cx="2971800" cy="458788"/>
+          </a:xfrm>
+          <a:prstGeom prst="rect">
+            <a:avLst/>
+          </a:prstGeom>
+        </p:spPr>
+        <p:txBody>
+          <a:bodyPr vert="horz" lIns="91440" tIns="45720" rIns="91440" bIns="45720" rtlCol="0"/>
+          <a:lstStyle>
+            <a:lvl1pPr algn="r">
+              <a:defRPr sz="1200"/>
+            </a:lvl1pPr>
+          </a:lstStyle>
+          <a:p>
+            <a:fld id="{A56E6D2A-88B1-4F5E-92C2-863BB0FD51D1}" type="datetimeFigureOut">
+              <a:rPr lang="en-GB" smtClean="0"/>
+              <a:t>20/04/2026</a:t>
+            </a:fld>
+            <a:endParaRPr lang="en-GB"/>
+          </a:p>
+        </p:txBody>
+      </p:sp>
+      <p:sp>
+        <p:nvSpPr>
+          <p:cNvPr id="4" name="Slide Image Placeholder 3"/>
+          <p:cNvSpPr>
+            <a:spLocks noGrp="1" noRot="1" noChangeAspect="1"/>
+          </p:cNvSpPr>
+          <p:nvPr>
+            <p:ph type="sldImg" idx="2"/>
+          </p:nvPr>
+        </p:nvSpPr>
+        <p:spPr>
+          <a:xfrm>
+            <a:off x="685800" y="1143000"/>
+            <a:ext cx="5486400" cy="3086100"/>
+          </a:xfrm>
+          <a:prstGeom prst="rect">
+            <a:avLst/>
+          </a:prstGeom>
+          <a:noFill/>
+          <a:ln w="12700">
+            <a:solidFill>
+              <a:prstClr val="black"/>
+            </a:solidFill>
+          </a:ln>
+        </p:spPr>
+        <p:txBody>
+          <a:bodyPr vert="horz" lIns="91440" tIns="45720" rIns="91440" bIns="45720" rtlCol="0" anchor="ctr"/>
+          <a:lstStyle/>
+          <a:p>
+            <a:endParaRPr lang="en-GB"/>
+          </a:p>
+        </p:txBody>
+      </p:sp>
+      <p:sp>
+        <p:nvSpPr>
+          <p:cNvPr id="5" name="Notes Placeholder 4"/>
+          <p:cNvSpPr>
+            <a:spLocks noGrp="1"/>
+          </p:cNvSpPr>
+          <p:nvPr>
+            <p:ph type="body" sz="quarter" idx="3"/>
+          </p:nvPr>
+        </p:nvSpPr>
+        <p:spPr>
+          <a:xfrm>
+            <a:off x="685800" y="4400550"/>
+            <a:ext cx="5486400" cy="3600450"/>
+          </a:xfrm>
+          <a:prstGeom prst="rect">
+            <a:avLst/>
+          </a:prstGeom>
+        </p:spPr>
+        <p:txBody>
+          <a:bodyPr vert="horz" lIns="91440" tIns="45720" rIns="91440" bIns="45720" rtlCol="0"/>
+          <a:lstStyle/>
+          <a:p>
+            <a:pPr lvl="0"/>
+            <a:r>
+              <a:rPr lang="en-US"/>
+              <a:t>Click to edit Master text styles</a:t>
+            </a:r>
+          </a:p>
+          <a:p>
+            <a:pPr lvl="1"/>
+            <a:r>
+              <a:rPr lang="en-US"/>
+              <a:t>Second level</a:t>
+            </a:r>
+          </a:p>
+          <a:p>
+            <a:pPr lvl="2"/>
+            <a:r>
+              <a:rPr lang="en-US"/>
+              <a:t>Third level</a:t>
+            </a:r>
+          </a:p>
+          <a:p>
+            <a:pPr lvl="3"/>
+            <a:r>
+              <a:rPr lang="en-US"/>
+              <a:t>Fourth level</a:t>
+            </a:r>
+          </a:p>
+          <a:p>
+            <a:pPr lvl="4"/>
+            <a:r>
+              <a:rPr lang="en-US"/>
+              <a:t>Fifth level</a:t>
+            </a:r>
+            <a:endParaRPr lang="en-GB"/>
+          </a:p>
+        </p:txBody>
+      </p:sp>
+      <p:sp>
+        <p:nvSpPr>
+          <p:cNvPr id="6" name="Footer Placeholder 5"/>
+          <p:cNvSpPr>
+            <a:spLocks noGrp="1"/>
+          </p:cNvSpPr>
+          <p:nvPr>
+            <p:ph type="ftr" sz="quarter" idx="4"/>
+          </p:nvPr>
+        </p:nvSpPr>
+        <p:spPr>
+          <a:xfrm>
+            <a:off x="0" y="8685213"/>
+            <a:ext cx="2971800" cy="458787"/>
+          </a:xfrm>
+          <a:prstGeom prst="rect">
+            <a:avLst/>
+          </a:prstGeom>
+        </p:spPr>
+        <p:txBody>
+          <a:bodyPr vert="horz" lIns="91440" tIns="45720" rIns="91440" bIns="45720" rtlCol="0" anchor="b"/>
+          <a:lstStyle>
+            <a:lvl1pPr algn="l">
+              <a:defRPr sz="1200"/>
+            </a:lvl1pPr>
+          </a:lstStyle>
+          <a:p>
+            <a:endParaRPr lang="en-GB"/>
+          </a:p>
+        </p:txBody>
+      </p:sp>
+      <p:sp>
+        <p:nvSpPr>
+          <p:cNvPr id="7" name="Slide Number Placeholder 6"/>
+          <p:cNvSpPr>
+            <a:spLocks noGrp="1"/>
+          </p:cNvSpPr>
+          <p:nvPr>
+            <p:ph type="sldNum" sz="quarter" idx="5"/>
+          </p:nvPr>
+        </p:nvSpPr>
+        <p:spPr>
+          <a:xfrm>
+            <a:off x="3884613" y="8685213"/>
+            <a:ext cx="2971800" cy="458787"/>
+          </a:xfrm>
+          <a:prstGeom prst="rect">
+            <a:avLst/>
+          </a:prstGeom>
+        </p:spPr>
+        <p:txBody>
+          <a:bodyPr vert="horz" lIns="91440" tIns="45720" rIns="91440" bIns="45720" rtlCol="0" anchor="b"/>
+          <a:lstStyle>
+            <a:lvl1pPr algn="r">
+              <a:defRPr sz="1200"/>
+            </a:lvl1pPr>
+          </a:lstStyle>
+          <a:p>
+            <a:fld id="{7042A0CC-B217-4AA5-BE94-261EE517D787}" type="slidenum">
+              <a:rPr lang="en-GB" smtClean="0"/>
+              <a:t>‹#›</a:t>
+            </a:fld>
+            <a:endParaRPr lang="en-GB"/>
+          </a:p>
+        </p:txBody>
+      </p:sp>
+    </p:spTree>
+    <p:extLst>
+      <p:ext uri="{BB962C8B-B14F-4D97-AF65-F5344CB8AC3E}">
+        <p14:creationId xmlns:p14="http://schemas.microsoft.com/office/powerpoint/2010/main" val="4069349382"/>
+      </p:ext>
+    </p:extLst>
+  </p:cSld>
+  <p:clrMap bg1="lt1" tx1="dk1" bg2="lt2" tx2="dk2" accent1="accent1" accent2="accent2" accent3="accent3" accent4="accent4" accent5="accent5" accent6="accent6" hlink="hlink" folHlink="folHlink"/>
+  <p:notesStyle>
+    <a:lvl1pPr marL="0" algn="l" defTabSz="914400" rtl="0" eaLnBrk="1" latinLnBrk="0" hangingPunct="1">
+      <a:defRPr sz="1200" kern="1200">
+        <a:solidFill>
+          <a:schemeClr val="tx1"/>
+        </a:solidFill>
+        <a:latin typeface="+mn-lt"/>
+        <a:ea typeface="+mn-ea"/>
+        <a:cs typeface="+mn-cs"/>
+      </a:defRPr>
+    </a:lvl1pPr>
+    <a:lvl2pPr marL="457200" algn="l" defTabSz="914400" rtl="0" eaLnBrk="1" latinLnBrk="0" hangingPunct="1">
+      <a:defRPr sz="1200" kern="1200">
+        <a:solidFill>
+          <a:schemeClr val="tx1"/>
+        </a:solidFill>
+        <a:latin typeface="+mn-lt"/>
+        <a:ea typeface="+mn-ea"/>
+        <a:cs typeface="+mn-cs"/>
+      </a:defRPr>
+    </a:lvl2pPr>
+    <a:lvl3pPr marL="914400" algn="l" defTabSz="914400" rtl="0" eaLnBrk="1" latinLnBrk="0" hangingPunct="1">
+      <a:defRPr sz="1200" kern="1200">
+        <a:solidFill>
+          <a:schemeClr val="tx1"/>
+        </a:solidFill>
+        <a:latin typeface="+mn-lt"/>
+        <a:ea typeface="+mn-ea"/>
+        <a:cs typeface="+mn-cs"/>
+      </a:defRPr>
+    </a:lvl3pPr>
+    <a:lvl4pPr marL="1371600" algn="l" defTabSz="914400" rtl="0" eaLnBrk="1" latinLnBrk="0" hangingPunct="1">
+      <a:defRPr sz="1200" kern="1200">
+        <a:solidFill>
+          <a:schemeClr val="tx1"/>
+        </a:solidFill>
+        <a:latin typeface="+mn-lt"/>
+        <a:ea typeface="+mn-ea"/>
+        <a:cs typeface="+mn-cs"/>
+      </a:defRPr>
+    </a:lvl4pPr>
+    <a:lvl5pPr marL="1828800" algn="l" defTabSz="914400" rtl="0" eaLnBrk="1" latinLnBrk="0" hangingPunct="1">
+      <a:defRPr sz="1200" kern="1200">
+        <a:solidFill>
+          <a:schemeClr val="tx1"/>
+        </a:solidFill>
+        <a:latin typeface="+mn-lt"/>
+        <a:ea typeface="+mn-ea"/>
+        <a:cs typeface="+mn-cs"/>
+      </a:defRPr>
+    </a:lvl5pPr>
+    <a:lvl6pPr marL="2286000" algn="l" defTabSz="914400" rtl="0" eaLnBrk="1" latinLnBrk="0" hangingPunct="1">
+      <a:defRPr sz="1200" kern="1200">
+        <a:solidFill>
+          <a:schemeClr val="tx1"/>
+        </a:solidFill>
+        <a:latin typeface="+mn-lt"/>
+        <a:ea typeface="+mn-ea"/>
+        <a:cs typeface="+mn-cs"/>
+      </a:defRPr>
+    </a:lvl6pPr>
+    <a:lvl7pPr marL="2743200" algn="l" defTabSz="914400" rtl="0" eaLnBrk="1" latinLnBrk="0" hangingPunct="1">
+      <a:defRPr sz="1200" kern="1200">
+        <a:solidFill>
+          <a:schemeClr val="tx1"/>
+        </a:solidFill>
+        <a:latin typeface="+mn-lt"/>
+        <a:ea typeface="+mn-ea"/>
+        <a:cs typeface="+mn-cs"/>
+      </a:defRPr>
+    </a:lvl7pPr>
+    <a:lvl8pPr marL="3200400" algn="l" defTabSz="914400" rtl="0" eaLnBrk="1" latinLnBrk="0" hangingPunct="1">
+      <a:defRPr sz="1200" kern="1200">
+        <a:solidFill>
+          <a:schemeClr val="tx1"/>
+        </a:solidFill>
+        <a:latin typeface="+mn-lt"/>
+        <a:ea typeface="+mn-ea"/>
+        <a:cs typeface="+mn-cs"/>
+      </a:defRPr>
+    </a:lvl8pPr>
+    <a:lvl9pPr marL="3657600" algn="l" defTabSz="914400" rtl="0" eaLnBrk="1" latinLnBrk="0" hangingPunct="1">
+      <a:defRPr sz="1200" kern="1200">
+        <a:solidFill>
+          <a:schemeClr val="tx1"/>
+        </a:solidFill>
+        <a:latin typeface="+mn-lt"/>
+        <a:ea typeface="+mn-ea"/>
+        <a:cs typeface="+mn-cs"/>
+      </a:defRPr>
+    </a:lvl9pPr>
+  </p:notesStyle>
+</p:notesMaster>
+</file>
+
+<file path=ppt/notesSlides/notesSlide1.xml><?xml version="1.0" encoding="utf-8"?>
+<p:notes xmlns:a="http://schemas.openxmlformats.org/drawingml/2006/main" xmlns:r="http://schemas.openxmlformats.org/officeDocument/2006/relationships" xmlns:p="http://schemas.openxmlformats.org/presentationml/2006/main">
+  <p:cSld>
+    <p:spTree>
+      <p:nvGrpSpPr>
+        <p:cNvPr id="1" name=""/>
+        <p:cNvGrpSpPr/>
+        <p:nvPr/>
+      </p:nvGrpSpPr>
+      <p:grpSpPr>
+        <a:xfrm>
+          <a:off x="0" y="0"/>
+          <a:ext cx="0" cy="0"/>
+          <a:chOff x="0" y="0"/>
+          <a:chExt cx="0" cy="0"/>
+        </a:xfrm>
+      </p:grpSpPr>
+      <p:sp>
+        <p:nvSpPr>
+          <p:cNvPr id="2" name="Slide Image Placeholder 1"/>
+          <p:cNvSpPr>
+            <a:spLocks noGrp="1" noRot="1" noChangeAspect="1"/>
+          </p:cNvSpPr>
+          <p:nvPr>
+            <p:ph type="sldImg"/>
+          </p:nvPr>
+        </p:nvSpPr>
+        <p:spPr/>
+      </p:sp>
+      <p:sp>
+        <p:nvSpPr>
+          <p:cNvPr id="3" name="Notes Placeholder 2"/>
+          <p:cNvSpPr>
+            <a:spLocks noGrp="1"/>
+          </p:cNvSpPr>
+          <p:nvPr>
+            <p:ph type="body" idx="1"/>
+          </p:nvPr>
+        </p:nvSpPr>
+        <p:spPr/>
+        <p:txBody>
+          <a:bodyPr/>
+          <a:lstStyle/>
+          <a:p>
+            <a:endParaRPr lang="en-GB" dirty="0"/>
+          </a:p>
+        </p:txBody>
+      </p:sp>
+      <p:sp>
+        <p:nvSpPr>
+          <p:cNvPr id="4" name="Slide Number Placeholder 3"/>
+          <p:cNvSpPr>
+            <a:spLocks noGrp="1"/>
+          </p:cNvSpPr>
+          <p:nvPr>
+            <p:ph type="sldNum" sz="quarter" idx="5"/>
+          </p:nvPr>
+        </p:nvSpPr>
+        <p:spPr/>
+        <p:txBody>
+          <a:bodyPr/>
+          <a:lstStyle/>
+          <a:p>
+            <a:fld id="{7042A0CC-B217-4AA5-BE94-261EE517D787}" type="slidenum">
+              <a:rPr lang="en-GB" smtClean="0"/>
+              <a:t>7</a:t>
+            </a:fld>
+            <a:endParaRPr lang="en-GB"/>
+          </a:p>
+        </p:txBody>
+      </p:sp>
+    </p:spTree>
+    <p:extLst>
+      <p:ext uri="{BB962C8B-B14F-4D97-AF65-F5344CB8AC3E}">
+        <p14:creationId xmlns:p14="http://schemas.microsoft.com/office/powerpoint/2010/main" val="3686367523"/>
+      </p:ext>
+    </p:extLst>
+  </p:cSld>
+  <p:clrMapOvr>
+    <a:masterClrMapping/>
+  </p:clrMapOvr>
+</p:notes>
+</file>
+
 <file path=ppt/slideLayouts/slideLayout1.xml><?xml version="1.0" encoding="utf-8"?>
 <p:sldLayout xmlns:a="http://schemas.openxmlformats.org/drawingml/2006/main" xmlns:r="http://schemas.openxmlformats.org/officeDocument/2006/relationships" xmlns:p="http://schemas.openxmlformats.org/presentationml/2006/main" type="title" preserve="1">
   <p:cSld name="Title Slide">
@@ -270,7 +707,7 @@
           <a:p>
             <a:fld id="{D03C9A7F-A4D0-47D6-B3FA-3E3F62E0CCCD}" type="datetimeFigureOut">
               <a:rPr lang="en-GB" smtClean="0"/>
-              <a:t>31/03/2026</a:t>
+              <a:t>20/04/2026</a:t>
             </a:fld>
             <a:endParaRPr lang="en-GB"/>
           </a:p>
@@ -470,7 +907,7 @@
           <a:p>
             <a:fld id="{D03C9A7F-A4D0-47D6-B3FA-3E3F62E0CCCD}" type="datetimeFigureOut">
               <a:rPr lang="en-GB" smtClean="0"/>
-              <a:t>31/03/2026</a:t>
+              <a:t>20/04/2026</a:t>
             </a:fld>
             <a:endParaRPr lang="en-GB"/>
           </a:p>
@@ -680,7 +1117,7 @@
           <a:p>
             <a:fld id="{D03C9A7F-A4D0-47D6-B3FA-3E3F62E0CCCD}" type="datetimeFigureOut">
               <a:rPr lang="en-GB" smtClean="0"/>
-              <a:t>31/03/2026</a:t>
+              <a:t>20/04/2026</a:t>
             </a:fld>
             <a:endParaRPr lang="en-GB"/>
           </a:p>
@@ -880,7 +1317,7 @@
           <a:p>
             <a:fld id="{D03C9A7F-A4D0-47D6-B3FA-3E3F62E0CCCD}" type="datetimeFigureOut">
               <a:rPr lang="en-GB" smtClean="0"/>
-              <a:t>31/03/2026</a:t>
+              <a:t>20/04/2026</a:t>
             </a:fld>
             <a:endParaRPr lang="en-GB"/>
           </a:p>
@@ -1156,7 +1593,7 @@
           <a:p>
             <a:fld id="{D03C9A7F-A4D0-47D6-B3FA-3E3F62E0CCCD}" type="datetimeFigureOut">
               <a:rPr lang="en-GB" smtClean="0"/>
-              <a:t>31/03/2026</a:t>
+              <a:t>20/04/2026</a:t>
             </a:fld>
             <a:endParaRPr lang="en-GB"/>
           </a:p>
@@ -1424,7 +1861,7 @@
           <a:p>
             <a:fld id="{D03C9A7F-A4D0-47D6-B3FA-3E3F62E0CCCD}" type="datetimeFigureOut">
               <a:rPr lang="en-GB" smtClean="0"/>
-              <a:t>31/03/2026</a:t>
+              <a:t>20/04/2026</a:t>
             </a:fld>
             <a:endParaRPr lang="en-GB"/>
           </a:p>
@@ -1839,7 +2276,7 @@
           <a:p>
             <a:fld id="{D03C9A7F-A4D0-47D6-B3FA-3E3F62E0CCCD}" type="datetimeFigureOut">
               <a:rPr lang="en-GB" smtClean="0"/>
-              <a:t>31/03/2026</a:t>
+              <a:t>20/04/2026</a:t>
             </a:fld>
             <a:endParaRPr lang="en-GB"/>
           </a:p>
@@ -1981,7 +2418,7 @@
           <a:p>
             <a:fld id="{D03C9A7F-A4D0-47D6-B3FA-3E3F62E0CCCD}" type="datetimeFigureOut">
               <a:rPr lang="en-GB" smtClean="0"/>
-              <a:t>31/03/2026</a:t>
+              <a:t>20/04/2026</a:t>
             </a:fld>
             <a:endParaRPr lang="en-GB"/>
           </a:p>
@@ -2094,7 +2531,7 @@
           <a:p>
             <a:fld id="{D03C9A7F-A4D0-47D6-B3FA-3E3F62E0CCCD}" type="datetimeFigureOut">
               <a:rPr lang="en-GB" smtClean="0"/>
-              <a:t>31/03/2026</a:t>
+              <a:t>20/04/2026</a:t>
             </a:fld>
             <a:endParaRPr lang="en-GB"/>
           </a:p>
@@ -2407,7 +2844,7 @@
           <a:p>
             <a:fld id="{D03C9A7F-A4D0-47D6-B3FA-3E3F62E0CCCD}" type="datetimeFigureOut">
               <a:rPr lang="en-GB" smtClean="0"/>
-              <a:t>31/03/2026</a:t>
+              <a:t>20/04/2026</a:t>
             </a:fld>
             <a:endParaRPr lang="en-GB"/>
           </a:p>
@@ -2696,7 +3133,7 @@
           <a:p>
             <a:fld id="{D03C9A7F-A4D0-47D6-B3FA-3E3F62E0CCCD}" type="datetimeFigureOut">
               <a:rPr lang="en-GB" smtClean="0"/>
-              <a:t>31/03/2026</a:t>
+              <a:t>20/04/2026</a:t>
             </a:fld>
             <a:endParaRPr lang="en-GB"/>
           </a:p>
@@ -2939,7 +3376,7 @@
           <a:p>
             <a:fld id="{D03C9A7F-A4D0-47D6-B3FA-3E3F62E0CCCD}" type="datetimeFigureOut">
               <a:rPr lang="en-GB" smtClean="0"/>
-              <a:t>31/03/2026</a:t>
+              <a:t>20/04/2026</a:t>
             </a:fld>
             <a:endParaRPr lang="en-GB"/>
           </a:p>
@@ -6117,36 +6554,6 @@
           <p:nvPr/>
         </p:nvPicPr>
         <p:blipFill>
-          <a:blip r:embed="rId2"/>
-          <a:stretch>
-            <a:fillRect/>
-          </a:stretch>
-        </p:blipFill>
-        <p:spPr>
-          <a:xfrm>
-            <a:off x="181236" y="631650"/>
-            <a:ext cx="3460117" cy="2595088"/>
-          </a:xfrm>
-          <a:prstGeom prst="rect">
-            <a:avLst/>
-          </a:prstGeom>
-        </p:spPr>
-      </p:pic>
-      <p:pic>
-        <p:nvPicPr>
-          <p:cNvPr id="5" name="Picture 4">
-            <a:extLst>
-              <a:ext uri="{FF2B5EF4-FFF2-40B4-BE49-F238E27FC236}">
-                <a16:creationId xmlns:a16="http://schemas.microsoft.com/office/drawing/2014/main" id="{923CB8CC-4161-EDEB-2F11-0F8D5D92B2B7}"/>
-              </a:ext>
-            </a:extLst>
-          </p:cNvPr>
-          <p:cNvPicPr>
-            <a:picLocks noChangeAspect="1"/>
-          </p:cNvPicPr>
-          <p:nvPr/>
-        </p:nvPicPr>
-        <p:blipFill>
           <a:blip r:embed="rId3"/>
           <a:stretch>
             <a:fillRect/>
@@ -6154,8 +6561,8 @@
         </p:blipFill>
         <p:spPr>
           <a:xfrm>
-            <a:off x="4044815" y="532117"/>
-            <a:ext cx="3725539" cy="2794154"/>
+            <a:off x="181236" y="631650"/>
+            <a:ext cx="3460117" cy="2595088"/>
           </a:xfrm>
           <a:prstGeom prst="rect">
             <a:avLst/>
@@ -6164,10 +6571,10 @@
       </p:pic>
       <p:pic>
         <p:nvPicPr>
-          <p:cNvPr id="11" name="Picture 10">
-            <a:extLst>
-              <a:ext uri="{FF2B5EF4-FFF2-40B4-BE49-F238E27FC236}">
-                <a16:creationId xmlns:a16="http://schemas.microsoft.com/office/drawing/2014/main" id="{9DE90A90-B792-247D-B732-C8BC218013F9}"/>
+          <p:cNvPr id="5" name="Picture 4">
+            <a:extLst>
+              <a:ext uri="{FF2B5EF4-FFF2-40B4-BE49-F238E27FC236}">
+                <a16:creationId xmlns:a16="http://schemas.microsoft.com/office/drawing/2014/main" id="{923CB8CC-4161-EDEB-2F11-0F8D5D92B2B7}"/>
               </a:ext>
             </a:extLst>
           </p:cNvPr>
@@ -6184,57 +6591,20 @@
         </p:blipFill>
         <p:spPr>
           <a:xfrm>
-            <a:off x="8019673" y="532116"/>
-            <a:ext cx="3512713" cy="2634535"/>
+            <a:off x="4044815" y="532117"/>
+            <a:ext cx="3725539" cy="2794154"/>
           </a:xfrm>
           <a:prstGeom prst="rect">
             <a:avLst/>
           </a:prstGeom>
         </p:spPr>
       </p:pic>
-      <p:sp>
-        <p:nvSpPr>
-          <p:cNvPr id="12" name="TextBox 11">
-            <a:extLst>
-              <a:ext uri="{FF2B5EF4-FFF2-40B4-BE49-F238E27FC236}">
-                <a16:creationId xmlns:a16="http://schemas.microsoft.com/office/drawing/2014/main" id="{E5EEA8B4-8C21-09FE-6D71-7F30B353C7B9}"/>
-              </a:ext>
-            </a:extLst>
-          </p:cNvPr>
-          <p:cNvSpPr txBox="1"/>
-          <p:nvPr/>
-        </p:nvSpPr>
-        <p:spPr>
-          <a:xfrm>
-            <a:off x="4294134" y="208951"/>
-            <a:ext cx="7496719" cy="646331"/>
-          </a:xfrm>
-          <a:prstGeom prst="rect">
-            <a:avLst/>
-          </a:prstGeom>
-          <a:solidFill>
-            <a:schemeClr val="bg1"/>
-          </a:solidFill>
-        </p:spPr>
-        <p:txBody>
-          <a:bodyPr wrap="square" rtlCol="0">
-            <a:spAutoFit/>
-          </a:bodyPr>
-          <a:lstStyle/>
-          <a:p>
-            <a:r>
-              <a:rPr lang="en-GB" dirty="0"/>
-              <a:t>Reduced background, red line fitted double exponential background, black(green) – 1D average of fig1:</a:t>
-            </a:r>
-          </a:p>
-        </p:txBody>
-      </p:sp>
       <p:pic>
         <p:nvPicPr>
-          <p:cNvPr id="18" name="Picture 17">
-            <a:extLst>
-              <a:ext uri="{FF2B5EF4-FFF2-40B4-BE49-F238E27FC236}">
-                <a16:creationId xmlns:a16="http://schemas.microsoft.com/office/drawing/2014/main" id="{C2F027E0-FA70-A676-67E3-3E5D57642634}"/>
+          <p:cNvPr id="11" name="Picture 10">
+            <a:extLst>
+              <a:ext uri="{FF2B5EF4-FFF2-40B4-BE49-F238E27FC236}">
+                <a16:creationId xmlns:a16="http://schemas.microsoft.com/office/drawing/2014/main" id="{9DE90A90-B792-247D-B732-C8BC218013F9}"/>
               </a:ext>
             </a:extLst>
           </p:cNvPr>
@@ -6251,8 +6621,8 @@
         </p:blipFill>
         <p:spPr>
           <a:xfrm>
-            <a:off x="89997" y="3548950"/>
-            <a:ext cx="4204137" cy="3153103"/>
+            <a:off x="8019673" y="532116"/>
+            <a:ext cx="3512713" cy="2634535"/>
           </a:xfrm>
           <a:prstGeom prst="rect">
             <a:avLst/>
@@ -6261,10 +6631,10 @@
       </p:pic>
       <p:sp>
         <p:nvSpPr>
-          <p:cNvPr id="28" name="TextBox 27">
-            <a:extLst>
-              <a:ext uri="{FF2B5EF4-FFF2-40B4-BE49-F238E27FC236}">
-                <a16:creationId xmlns:a16="http://schemas.microsoft.com/office/drawing/2014/main" id="{492E0D54-FC04-E909-D589-611233A3540A}"/>
+          <p:cNvPr id="12" name="TextBox 11">
+            <a:extLst>
+              <a:ext uri="{FF2B5EF4-FFF2-40B4-BE49-F238E27FC236}">
+                <a16:creationId xmlns:a16="http://schemas.microsoft.com/office/drawing/2014/main" id="{E5EEA8B4-8C21-09FE-6D71-7F30B353C7B9}"/>
               </a:ext>
             </a:extLst>
           </p:cNvPr>
@@ -6273,69 +6643,35 @@
         </p:nvSpPr>
         <p:spPr>
           <a:xfrm>
-            <a:off x="4160127" y="3531730"/>
-            <a:ext cx="3076245" cy="1107996"/>
-          </a:xfrm>
-          <a:prstGeom prst="rect">
-            <a:avLst/>
-          </a:prstGeom>
-          <a:noFill/>
-        </p:spPr>
-        <p:txBody>
-          <a:bodyPr wrap="square">
+            <a:off x="4294134" y="208951"/>
+            <a:ext cx="7496719" cy="646331"/>
+          </a:xfrm>
+          <a:prstGeom prst="rect">
+            <a:avLst/>
+          </a:prstGeom>
+          <a:solidFill>
+            <a:schemeClr val="bg1"/>
+          </a:solidFill>
+        </p:spPr>
+        <p:txBody>
+          <a:bodyPr wrap="square" rtlCol="0">
             <a:spAutoFit/>
           </a:bodyPr>
           <a:lstStyle/>
           <a:p>
             <a:r>
-              <a:rPr lang="en-GB" dirty="0" err="1"/>
-              <a:t>Fitpar</a:t>
-            </a:r>
-            <a:r>
               <a:rPr lang="en-GB" dirty="0"/>
-              <a:t>:</a:t>
-            </a:r>
-          </a:p>
-          <a:p>
-            <a:r>
-              <a:rPr lang="en-GB" sz="1200" dirty="0"/>
-              <a:t>p: [1 8 71.5080 0.5022 0 0 0 15.6398 0 0]</a:t>
-            </a:r>
-          </a:p>
-          <a:p>
-            <a:r>
-              <a:rPr lang="en-GB" sz="1200" dirty="0"/>
-              <a:t>          sig: [0 0 2.3643 0.0144 0 0 0 0.0777 0 0]</a:t>
-            </a:r>
-          </a:p>
-          <a:p>
-            <a:r>
-              <a:rPr lang="en-GB" sz="1200" dirty="0"/>
-              <a:t>           bp: [1.4084 0.0261 0.0029 4.5656e-04]</a:t>
-            </a:r>
-          </a:p>
-          <a:p>
-            <a:r>
-              <a:rPr lang="en-GB" sz="1200" dirty="0"/>
-              <a:t>         </a:t>
-            </a:r>
-            <a:r>
-              <a:rPr lang="en-GB" sz="1200" dirty="0" err="1"/>
-              <a:t>bsig</a:t>
-            </a:r>
-            <a:r>
-              <a:rPr lang="en-GB" sz="1200" dirty="0"/>
-              <a:t>: [0.6440 0.0033 0.0018 0.0029]</a:t>
+              <a:t>Reduced background, red line fitted double exponential background, black(green) – 1D average of fig1:</a:t>
             </a:r>
           </a:p>
         </p:txBody>
       </p:sp>
       <p:pic>
         <p:nvPicPr>
-          <p:cNvPr id="34" name="Picture 33">
-            <a:extLst>
-              <a:ext uri="{FF2B5EF4-FFF2-40B4-BE49-F238E27FC236}">
-                <a16:creationId xmlns:a16="http://schemas.microsoft.com/office/drawing/2014/main" id="{C129EFDF-92CE-F69C-E00B-57314BB778CA}"/>
+          <p:cNvPr id="18" name="Picture 17">
+            <a:extLst>
+              <a:ext uri="{FF2B5EF4-FFF2-40B4-BE49-F238E27FC236}">
+                <a16:creationId xmlns:a16="http://schemas.microsoft.com/office/drawing/2014/main" id="{C2F027E0-FA70-A676-67E3-3E5D57642634}"/>
               </a:ext>
             </a:extLst>
           </p:cNvPr>
@@ -6346,6 +6682,107 @@
         </p:nvPicPr>
         <p:blipFill>
           <a:blip r:embed="rId6"/>
+          <a:stretch>
+            <a:fillRect/>
+          </a:stretch>
+        </p:blipFill>
+        <p:spPr>
+          <a:xfrm>
+            <a:off x="89997" y="3548950"/>
+            <a:ext cx="4204137" cy="3153103"/>
+          </a:xfrm>
+          <a:prstGeom prst="rect">
+            <a:avLst/>
+          </a:prstGeom>
+        </p:spPr>
+      </p:pic>
+      <p:sp>
+        <p:nvSpPr>
+          <p:cNvPr id="28" name="TextBox 27">
+            <a:extLst>
+              <a:ext uri="{FF2B5EF4-FFF2-40B4-BE49-F238E27FC236}">
+                <a16:creationId xmlns:a16="http://schemas.microsoft.com/office/drawing/2014/main" id="{492E0D54-FC04-E909-D589-611233A3540A}"/>
+              </a:ext>
+            </a:extLst>
+          </p:cNvPr>
+          <p:cNvSpPr txBox="1"/>
+          <p:nvPr/>
+        </p:nvSpPr>
+        <p:spPr>
+          <a:xfrm>
+            <a:off x="4160127" y="3531730"/>
+            <a:ext cx="3076245" cy="1107996"/>
+          </a:xfrm>
+          <a:prstGeom prst="rect">
+            <a:avLst/>
+          </a:prstGeom>
+          <a:noFill/>
+        </p:spPr>
+        <p:txBody>
+          <a:bodyPr wrap="square">
+            <a:spAutoFit/>
+          </a:bodyPr>
+          <a:lstStyle/>
+          <a:p>
+            <a:r>
+              <a:rPr lang="en-GB" dirty="0" err="1"/>
+              <a:t>Fitpar</a:t>
+            </a:r>
+            <a:r>
+              <a:rPr lang="en-GB" dirty="0"/>
+              <a:t>:</a:t>
+            </a:r>
+          </a:p>
+          <a:p>
+            <a:r>
+              <a:rPr lang="en-GB" sz="1200" dirty="0"/>
+              <a:t>p: [1 8 71.5080 0.5022 0 0 0 15.6398 0 0]</a:t>
+            </a:r>
+          </a:p>
+          <a:p>
+            <a:r>
+              <a:rPr lang="en-GB" sz="1200" dirty="0"/>
+              <a:t>          sig: [0 0 2.3643 0.0144 0 0 0 0.0777 0 0]</a:t>
+            </a:r>
+          </a:p>
+          <a:p>
+            <a:r>
+              <a:rPr lang="en-GB" sz="1200" dirty="0"/>
+              <a:t>           bp: [1.4084 0.0261 0.0029 4.5656e-04]</a:t>
+            </a:r>
+          </a:p>
+          <a:p>
+            <a:r>
+              <a:rPr lang="en-GB" sz="1200" dirty="0"/>
+              <a:t>         </a:t>
+            </a:r>
+            <a:r>
+              <a:rPr lang="en-GB" sz="1200" dirty="0" err="1"/>
+              <a:t>bsig</a:t>
+            </a:r>
+            <a:r>
+              <a:rPr lang="en-GB" sz="1200" dirty="0"/>
+              <a:t>: [0.6440 0.0033 0.0018 0.0029]</a:t>
+            </a:r>
+          </a:p>
+        </p:txBody>
+      </p:sp>
+      <p:pic>
+        <p:nvPicPr>
+          <p:cNvPr id="34" name="Picture 33">
+            <a:extLst>
+              <a:ext uri="{FF2B5EF4-FFF2-40B4-BE49-F238E27FC236}">
+                <a16:creationId xmlns:a16="http://schemas.microsoft.com/office/drawing/2014/main" id="{C129EFDF-92CE-F69C-E00B-57314BB778CA}"/>
+              </a:ext>
+            </a:extLst>
+          </p:cNvPr>
+          <p:cNvPicPr>
+            <a:picLocks noChangeAspect="1"/>
+          </p:cNvPicPr>
+          <p:nvPr/>
+        </p:nvPicPr>
+        <p:blipFill>
+          <a:blip r:embed="rId7"/>
           <a:stretch>
             <a:fillRect/>
           </a:stretch>
@@ -7283,4 +7720,319 @@
     </a:ext>
   </a:extLst>
 </a:theme>
+</file>
+
+<file path=ppt/theme/theme2.xml><?xml version="1.0" encoding="utf-8"?>
+<a:theme xmlns:a="http://schemas.openxmlformats.org/drawingml/2006/main" name="Office Theme">
+  <a:themeElements>
+    <a:clrScheme name="Office">
+      <a:dk1>
+        <a:sysClr val="windowText" lastClr="000000"/>
+      </a:dk1>
+      <a:lt1>
+        <a:sysClr val="window" lastClr="FFFFFF"/>
+      </a:lt1>
+      <a:dk2>
+        <a:srgbClr val="0E2841"/>
+      </a:dk2>
+      <a:lt2>
+        <a:srgbClr val="E8E8E8"/>
+      </a:lt2>
+      <a:accent1>
+        <a:srgbClr val="156082"/>
+      </a:accent1>
+      <a:accent2>
+        <a:srgbClr val="E97132"/>
+      </a:accent2>
+      <a:accent3>
+        <a:srgbClr val="196B24"/>
+      </a:accent3>
+      <a:accent4>
+        <a:srgbClr val="0F9ED5"/>
+      </a:accent4>
+      <a:accent5>
+        <a:srgbClr val="A02B93"/>
+      </a:accent5>
+      <a:accent6>
+        <a:srgbClr val="4EA72E"/>
+      </a:accent6>
+      <a:hlink>
+        <a:srgbClr val="467886"/>
+      </a:hlink>
+      <a:folHlink>
+        <a:srgbClr val="96607D"/>
+      </a:folHlink>
+    </a:clrScheme>
+    <a:fontScheme name="Office">
+      <a:majorFont>
+        <a:latin typeface="Aptos Display" panose="02110004020202020204"/>
+        <a:ea typeface=""/>
+        <a:cs typeface=""/>
+        <a:font script="Jpan" typeface="游ゴシック Light"/>
+        <a:font script="Hang" typeface="맑은 고딕"/>
+        <a:font script="Hans" typeface="等线 Light"/>
+        <a:font script="Hant" typeface="新細明體"/>
+        <a:font script="Arab" typeface="Times New Roman"/>
+        <a:font script="Hebr" typeface="Times New Roman"/>
+        <a:font script="Thai" typeface="Angsana New"/>
+        <a:font script="Ethi" typeface="Nyala"/>
+        <a:font script="Beng" typeface="Vrinda"/>
+        <a:font script="Gujr" typeface="Shruti"/>
+        <a:font script="Khmr" typeface="MoolBoran"/>
+        <a:font script="Knda" typeface="Tunga"/>
+        <a:font script="Guru" typeface="Raavi"/>
+        <a:font script="Cans" typeface="Euphemia"/>
+        <a:font script="Cher" typeface="Plantagenet Cherokee"/>
+        <a:font script="Yiii" typeface="Microsoft Yi Baiti"/>
+        <a:font script="Tibt" typeface="Microsoft Himalaya"/>
+        <a:font script="Thaa" typeface="MV Boli"/>
+        <a:font script="Deva" typeface="Mangal"/>
+        <a:font script="Telu" typeface="Gautami"/>
+        <a:font script="Taml" typeface="Latha"/>
+        <a:font script="Syrc" typeface="Estrangelo Edessa"/>
+        <a:font script="Orya" typeface="Kalinga"/>
+        <a:font script="Mlym" typeface="Kartika"/>
+        <a:font script="Laoo" typeface="DokChampa"/>
+        <a:font script="Sinh" typeface="Iskoola Pota"/>
+        <a:font script="Mong" typeface="Mongolian Baiti"/>
+        <a:font script="Viet" typeface="Times New Roman"/>
+        <a:font script="Uigh" typeface="Microsoft Uighur"/>
+        <a:font script="Geor" typeface="Sylfaen"/>
+        <a:font script="Armn" typeface="Arial"/>
+        <a:font script="Bugi" typeface="Leelawadee UI"/>
+        <a:font script="Bopo" typeface="Microsoft JhengHei"/>
+        <a:font script="Java" typeface="Javanese Text"/>
+        <a:font script="Lisu" typeface="Segoe UI"/>
+        <a:font script="Mymr" typeface="Myanmar Text"/>
+        <a:font script="Nkoo" typeface="Ebrima"/>
+        <a:font script="Olck" typeface="Nirmala UI"/>
+        <a:font script="Osma" typeface="Ebrima"/>
+        <a:font script="Phag" typeface="Phagspa"/>
+        <a:font script="Syrn" typeface="Estrangelo Edessa"/>
+        <a:font script="Syrj" typeface="Estrangelo Edessa"/>
+        <a:font script="Syre" typeface="Estrangelo Edessa"/>
+        <a:font script="Sora" typeface="Nirmala UI"/>
+        <a:font script="Tale" typeface="Microsoft Tai Le"/>
+        <a:font script="Talu" typeface="Microsoft New Tai Lue"/>
+        <a:font script="Tfng" typeface="Ebrima"/>
+      </a:majorFont>
+      <a:minorFont>
+        <a:latin typeface="Aptos" panose="02110004020202020204"/>
+        <a:ea typeface=""/>
+        <a:cs typeface=""/>
+        <a:font script="Jpan" typeface="游ゴシック"/>
+        <a:font script="Hang" typeface="맑은 고딕"/>
+        <a:font script="Hans" typeface="等线"/>
+        <a:font script="Hant" typeface="新細明體"/>
+        <a:font script="Arab" typeface="Arial"/>
+        <a:font script="Hebr" typeface="Arial"/>
+        <a:font script="Thai" typeface="Cordia New"/>
+        <a:font script="Ethi" typeface="Nyala"/>
+        <a:font script="Beng" typeface="Vrinda"/>
+        <a:font script="Gujr" typeface="Shruti"/>
+        <a:font script="Khmr" typeface="DaunPenh"/>
+        <a:font script="Knda" typeface="Tunga"/>
+        <a:font script="Guru" typeface="Raavi"/>
+        <a:font script="Cans" typeface="Euphemia"/>
+        <a:font script="Cher" typeface="Plantagenet Cherokee"/>
+        <a:font script="Yiii" typeface="Microsoft Yi Baiti"/>
+        <a:font script="Tibt" typeface="Microsoft Himalaya"/>
+        <a:font script="Thaa" typeface="MV Boli"/>
+        <a:font script="Deva" typeface="Mangal"/>
+        <a:font script="Telu" typeface="Gautami"/>
+        <a:font script="Taml" typeface="Latha"/>
+        <a:font script="Syrc" typeface="Estrangelo Edessa"/>
+        <a:font script="Orya" typeface="Kalinga"/>
+        <a:font script="Mlym" typeface="Kartika"/>
+        <a:font script="Laoo" typeface="DokChampa"/>
+        <a:font script="Sinh" typeface="Iskoola Pota"/>
+        <a:font script="Mong" typeface="Mongolian Baiti"/>
+        <a:font script="Viet" typeface="Arial"/>
+        <a:font script="Uigh" typeface="Microsoft Uighur"/>
+        <a:font script="Geor" typeface="Sylfaen"/>
+        <a:font script="Armn" typeface="Arial"/>
+        <a:font script="Bugi" typeface="Leelawadee UI"/>
+        <a:font script="Bopo" typeface="Microsoft JhengHei"/>
+        <a:font script="Java" typeface="Javanese Text"/>
+        <a:font script="Lisu" typeface="Segoe UI"/>
+        <a:font script="Mymr" typeface="Myanmar Text"/>
+        <a:font script="Nkoo" typeface="Ebrima"/>
+        <a:font script="Olck" typeface="Nirmala UI"/>
+        <a:font script="Osma" typeface="Ebrima"/>
+        <a:font script="Phag" typeface="Phagspa"/>
+        <a:font script="Syrn" typeface="Estrangelo Edessa"/>
+        <a:font script="Syrj" typeface="Estrangelo Edessa"/>
+        <a:font script="Syre" typeface="Estrangelo Edessa"/>
+        <a:font script="Sora" typeface="Nirmala UI"/>
+        <a:font script="Tale" typeface="Microsoft Tai Le"/>
+        <a:font script="Talu" typeface="Microsoft New Tai Lue"/>
+        <a:font script="Tfng" typeface="Ebrima"/>
+      </a:minorFont>
+    </a:fontScheme>
+    <a:fmtScheme name="Office">
+      <a:fillStyleLst>
+        <a:solidFill>
+          <a:schemeClr val="phClr"/>
+        </a:solidFill>
+        <a:gradFill rotWithShape="1">
+          <a:gsLst>
+            <a:gs pos="0">
+              <a:schemeClr val="phClr">
+                <a:lumMod val="110000"/>
+                <a:satMod val="105000"/>
+                <a:tint val="67000"/>
+              </a:schemeClr>
+            </a:gs>
+            <a:gs pos="50000">
+              <a:schemeClr val="phClr">
+                <a:lumMod val="105000"/>
+                <a:satMod val="103000"/>
+                <a:tint val="73000"/>
+              </a:schemeClr>
+            </a:gs>
+            <a:gs pos="100000">
+              <a:schemeClr val="phClr">
+                <a:lumMod val="105000"/>
+                <a:satMod val="109000"/>
+                <a:tint val="81000"/>
+              </a:schemeClr>
+            </a:gs>
+          </a:gsLst>
+          <a:lin ang="5400000" scaled="0"/>
+        </a:gradFill>
+        <a:gradFill rotWithShape="1">
+          <a:gsLst>
+            <a:gs pos="0">
+              <a:schemeClr val="phClr">
+                <a:satMod val="103000"/>
+                <a:lumMod val="102000"/>
+                <a:tint val="94000"/>
+              </a:schemeClr>
+            </a:gs>
+            <a:gs pos="50000">
+              <a:schemeClr val="phClr">
+                <a:satMod val="110000"/>
+                <a:lumMod val="100000"/>
+                <a:shade val="100000"/>
+              </a:schemeClr>
+            </a:gs>
+            <a:gs pos="100000">
+              <a:schemeClr val="phClr">
+                <a:lumMod val="99000"/>
+                <a:satMod val="120000"/>
+                <a:shade val="78000"/>
+              </a:schemeClr>
+            </a:gs>
+          </a:gsLst>
+          <a:lin ang="5400000" scaled="0"/>
+        </a:gradFill>
+      </a:fillStyleLst>
+      <a:lnStyleLst>
+        <a:ln w="12700" cap="flat" cmpd="sng" algn="ctr">
+          <a:solidFill>
+            <a:schemeClr val="phClr"/>
+          </a:solidFill>
+          <a:prstDash val="solid"/>
+          <a:miter lim="800000"/>
+        </a:ln>
+        <a:ln w="19050" cap="flat" cmpd="sng" algn="ctr">
+          <a:solidFill>
+            <a:schemeClr val="phClr"/>
+          </a:solidFill>
+          <a:prstDash val="solid"/>
+          <a:miter lim="800000"/>
+        </a:ln>
+        <a:ln w="25400" cap="flat" cmpd="sng" algn="ctr">
+          <a:solidFill>
+            <a:schemeClr val="phClr"/>
+          </a:solidFill>
+          <a:prstDash val="solid"/>
+          <a:miter lim="800000"/>
+        </a:ln>
+      </a:lnStyleLst>
+      <a:effectStyleLst>
+        <a:effectStyle>
+          <a:effectLst/>
+        </a:effectStyle>
+        <a:effectStyle>
+          <a:effectLst/>
+        </a:effectStyle>
+        <a:effectStyle>
+          <a:effectLst>
+            <a:outerShdw blurRad="57150" dist="19050" dir="5400000" algn="ctr" rotWithShape="0">
+              <a:srgbClr val="000000">
+                <a:alpha val="63000"/>
+              </a:srgbClr>
+            </a:outerShdw>
+          </a:effectLst>
+        </a:effectStyle>
+      </a:effectStyleLst>
+      <a:bgFillStyleLst>
+        <a:solidFill>
+          <a:schemeClr val="phClr"/>
+        </a:solidFill>
+        <a:solidFill>
+          <a:schemeClr val="phClr">
+            <a:tint val="95000"/>
+            <a:satMod val="170000"/>
+          </a:schemeClr>
+        </a:solidFill>
+        <a:gradFill rotWithShape="1">
+          <a:gsLst>
+            <a:gs pos="0">
+              <a:schemeClr val="phClr">
+                <a:tint val="93000"/>
+                <a:satMod val="150000"/>
+                <a:shade val="98000"/>
+                <a:lumMod val="102000"/>
+              </a:schemeClr>
+            </a:gs>
+            <a:gs pos="50000">
+              <a:schemeClr val="phClr">
+                <a:tint val="98000"/>
+                <a:satMod val="130000"/>
+                <a:shade val="90000"/>
+                <a:lumMod val="103000"/>
+              </a:schemeClr>
+            </a:gs>
+            <a:gs pos="100000">
+              <a:schemeClr val="phClr">
+                <a:shade val="63000"/>
+                <a:satMod val="120000"/>
+              </a:schemeClr>
+            </a:gs>
+          </a:gsLst>
+          <a:lin ang="5400000" scaled="0"/>
+        </a:gradFill>
+      </a:bgFillStyleLst>
+    </a:fmtScheme>
+  </a:themeElements>
+  <a:objectDefaults>
+    <a:lnDef>
+      <a:spPr/>
+      <a:bodyPr/>
+      <a:lstStyle/>
+      <a:style>
+        <a:lnRef idx="2">
+          <a:schemeClr val="accent1"/>
+        </a:lnRef>
+        <a:fillRef idx="0">
+          <a:schemeClr val="accent1"/>
+        </a:fillRef>
+        <a:effectRef idx="1">
+          <a:schemeClr val="accent1"/>
+        </a:effectRef>
+        <a:fontRef idx="minor">
+          <a:schemeClr val="tx1"/>
+        </a:fontRef>
+      </a:style>
+    </a:lnDef>
+  </a:objectDefaults>
+  <a:extraClrSchemeLst/>
+  <a:extLst>
+    <a:ext uri="{05A4C25C-085E-4340-85A3-A5531E510DB2}">
+      <thm15:themeFamily xmlns:thm15="http://schemas.microsoft.com/office/thememl/2012/main" name="Office Theme" id="{2E142A2C-CD16-42D6-873A-C26D2A0506FA}" vid="{1BDDFF52-6CD6-40A5-AB3C-68EB2F1E4D0A}"/>
+    </a:ext>
+  </a:extLst>
+</a:theme>
 </file>
</xml_diff>